<commit_message>
made changes to the evol website
</commit_message>
<xml_diff>
--- a/teaching/CS472/Timetable/ClassOverview-V2.pptx
+++ b/teaching/CS472/Timetable/ClassOverview-V2.pptx
@@ -19506,6 +19506,28 @@
             <a:endParaRPr lang="en-GB" dirty="0"/>
           </a:p>
           <a:p>
+            <a:r>
+              <a:rPr lang="en-BE" dirty="0"/>
+              <a:t>My Lab - </a:t>
+            </a:r>
+            <a:r>
+              <a:rPr lang="en-GB" dirty="0">
+                <a:hlinkClick r:id="rId4"/>
+              </a:rPr>
+              <a:t>https://unlv-evol.github.io</a:t>
+            </a:r>
+            <a:r>
+              <a:rPr lang="en-GB">
+                <a:hlinkClick r:id="rId4"/>
+              </a:rPr>
+              <a:t>/</a:t>
+            </a:r>
+            <a:endParaRPr lang="en-GB"/>
+          </a:p>
+          <a:p>
+            <a:pPr marL="0" indent="0">
+              <a:buNone/>
+            </a:pPr>
             <a:endParaRPr lang="en-BE" dirty="0"/>
           </a:p>
         </p:txBody>

</xml_diff>